<commit_message>
docs: fill assessment name and presenter on deck cover
Co-Authored-By: Claude Opus 4.8 <noreply@anthropic.com>
</commit_message>
<xml_diff>
--- a/docs/Policy-Overview-Dashboard.pptx
+++ b/docs/Policy-Overview-Dashboard.pptx
@@ -4700,7 +4700,7 @@
                 <a:latin typeface="HCLTech Roobert" panose="020B0504030202060203" pitchFamily="34" charset="0"/>
                 <a:cs typeface="HCLTech Roobert" panose="020B0504030202060203" pitchFamily="34" charset="0"/>
               </a:rPr>
-              <a:t>&lt; Assessment Name &gt;</a:t>
+              <a:t>Policy Overview Dashboard</a:t>
             </a:r>
           </a:p>
           <a:p>
@@ -4715,7 +4715,7 @@
                 <a:latin typeface="HCLTech Roobert" panose="020B0504030202060203" pitchFamily="34" charset="0"/>
                 <a:cs typeface="HCLTech Roobert" panose="020B0504030202060203" pitchFamily="34" charset="0"/>
               </a:rPr>
-              <a:t>By &lt;Resource Name&gt;</a:t>
+              <a:t>By Ravi G</a:t>
             </a:r>
           </a:p>
         </p:txBody>

</xml_diff>